<commit_message>
[MSC-49] Refine random groups, seeded articles and operator configuration
Consolidate random-room scheduler/chat behavior, operator settings,
ticket/article fixtures and frontend publication/security-workflow updates.

Original-snapshot: a5e029be7b344102e20aa74913a005d94ea3feee
Co-authored-by: fssrepository <45578746+fssrepository@users.noreply.github.com>

Tasks: fssrepository/myscoutee-roadmap#49
</commit_message>
<xml_diff>
--- a/guides/pitches/network-output/MyScoutee_Network_Pitch_v1.0.0_EN.pptx
+++ b/guides/pitches/network-output/MyScoutee_Network_Pitch_v1.0.0_EN.pptx
@@ -69,7 +69,7 @@
         <p:txBody>
           <a:bodyPr/>
           <a:p>
-            <a:fld id="{A02A89F0-1FAA-49D0-8AB8-84732FD7B29E}" type="slidenum">
+            <a:fld id="{563C91A8-C9A1-4C35-82B8-82DCC837CDF8}" type="slidenum">
               <a:t>&lt;#&gt;</a:t>
             </a:fld>
           </a:p>
@@ -257,7 +257,7 @@
         <p:txBody>
           <a:bodyPr/>
           <a:p>
-            <a:fld id="{E45C950E-3843-449E-8A28-1DABADE00B0C}" type="slidenum">
+            <a:fld id="{44FFFBCC-6652-4AD6-8B19-ACD9AEA39161}" type="slidenum">
               <a:t>&lt;#&gt;</a:t>
             </a:fld>
           </a:p>
@@ -513,7 +513,7 @@
         <p:txBody>
           <a:bodyPr/>
           <a:p>
-            <a:fld id="{9692F790-186C-426A-9866-29AFE9C94A5F}" type="slidenum">
+            <a:fld id="{7FDA673C-F4DE-4E20-A948-AF975D471C93}" type="slidenum">
               <a:t>&lt;#&gt;</a:t>
             </a:fld>
           </a:p>
@@ -837,7 +837,7 @@
         <p:txBody>
           <a:bodyPr/>
           <a:p>
-            <a:fld id="{B6C2FB9E-2285-4634-873E-A93B07CEDCE4}" type="slidenum">
+            <a:fld id="{3F179F2A-2CA7-4836-856F-820A4FC7F0D1}" type="slidenum">
               <a:t>&lt;#&gt;</a:t>
             </a:fld>
           </a:p>
@@ -994,7 +994,7 @@
         <p:txBody>
           <a:bodyPr/>
           <a:p>
-            <a:fld id="{BAD6DE34-306B-40C1-B14D-1F851BC42671}" type="slidenum">
+            <a:fld id="{2DD2CFC2-A16A-417E-86EA-DD031DCB06D4}" type="slidenum">
               <a:t>&lt;#&gt;</a:t>
             </a:fld>
           </a:p>
@@ -1148,7 +1148,7 @@
         <p:txBody>
           <a:bodyPr/>
           <a:p>
-            <a:fld id="{712E89AA-0274-42F6-BB59-6BBCBC67B0E5}" type="slidenum">
+            <a:fld id="{D5B75F6F-56D2-47EE-8678-09E37EA2EB11}" type="slidenum">
               <a:t>&lt;#&gt;</a:t>
             </a:fld>
           </a:p>
@@ -1336,7 +1336,7 @@
         <p:txBody>
           <a:bodyPr/>
           <a:p>
-            <a:fld id="{934A9DBB-3E1B-4C54-9292-0B05F64DF45E}" type="slidenum">
+            <a:fld id="{ED99E6AD-048A-4FF2-88B5-6931F572DDFC}" type="slidenum">
               <a:t>&lt;#&gt;</a:t>
             </a:fld>
           </a:p>
@@ -1456,7 +1456,7 @@
         <p:txBody>
           <a:bodyPr/>
           <a:p>
-            <a:fld id="{D32FCB90-CC9A-4F47-A2BF-D659D076E82F}" type="slidenum">
+            <a:fld id="{EED15FB8-FEEF-4E36-BE1E-63644856656F}" type="slidenum">
               <a:t>&lt;#&gt;</a:t>
             </a:fld>
           </a:p>
@@ -1576,7 +1576,7 @@
         <p:txBody>
           <a:bodyPr/>
           <a:p>
-            <a:fld id="{70BD465E-90E3-4461-8C9F-8A2F1D00F491}" type="slidenum">
+            <a:fld id="{6C88F7AA-2F72-44C6-89F6-5789492E5CA1}" type="slidenum">
               <a:t>&lt;#&gt;</a:t>
             </a:fld>
           </a:p>
@@ -1798,7 +1798,7 @@
         <p:txBody>
           <a:bodyPr/>
           <a:p>
-            <a:fld id="{01F2ED90-1C58-4BC7-8311-5097307FE902}" type="slidenum">
+            <a:fld id="{2E7D980E-CCFB-42F7-8C90-7215793DDCCC}" type="slidenum">
               <a:t>&lt;#&gt;</a:t>
             </a:fld>
           </a:p>
@@ -2020,7 +2020,7 @@
         <p:txBody>
           <a:bodyPr/>
           <a:p>
-            <a:fld id="{857B7A39-8014-483C-AFDF-78621A89AC39}" type="slidenum">
+            <a:fld id="{6A294871-666E-4E3D-88B3-AD5A9D7C1C07}" type="slidenum">
               <a:t>&lt;#&gt;</a:t>
             </a:fld>
           </a:p>
@@ -2242,7 +2242,7 @@
         <p:txBody>
           <a:bodyPr/>
           <a:p>
-            <a:fld id="{A1A0E55C-732B-4DFE-98D1-FBCD201A00A4}" type="slidenum">
+            <a:fld id="{4843B596-84F2-4556-B62A-0DE70C4601CD}" type="slidenum">
               <a:t>&lt;#&gt;</a:t>
             </a:fld>
           </a:p>
@@ -2654,7 +2654,7 @@
             <a:pPr algn="r">
               <a:buNone/>
             </a:pPr>
-            <a:fld id="{BEED0D9D-164A-4882-90D3-07249548F701}" type="slidenum">
+            <a:fld id="{B0D57F52-F815-41F1-99FA-74B468F046E9}" type="slidenum">
               <a:rPr b="0" lang="en-US" sz="1400" spc="-1" strike="noStrike">
                 <a:latin typeface="Times New Roman"/>
               </a:rPr>

</xml_diff>